<commit_message>
Rebuild the deck against the corrected test and commit counts
The Quality slide reports figures that move whenever anything lands, and
three of them had drifted: JavaScript tests passing (359 -> 370), tests
defined (372 -> 382), and skipped (13 -> 12). Two of those moves are the
warm-up tests from the previous commit; the rest was already stale before
it, because the suite had grown to 379 without the slide following.

The commit count reads 106, which is what `git rev-list --count HEAD`
becomes once this commit is in — the same convention the previous rebuilds
used, and the only way a self-referential figure can be right rather than
one behind.

Migration count left at 11: supabase/migrations/ holds eleven files even
though the numbering runs to 0012, because 0006 was never used. The number
on the slide counts files, which is what the re-derive note tells a reader
to check.

Co-Authored-By: Claude Opus 5 (1M context) <noreply@anthropic.com>
</commit_message>
<xml_diff>
--- a/ARAH-System-Overview.pptx
+++ b/ARAH-System-Overview.pptx
@@ -14412,7 +14412,7 @@
                 <a:ea typeface="Consolas" pitchFamily="34" charset="-122"/>
                 <a:cs typeface="Consolas" pitchFamily="34" charset="-120"/>
               </a:rPr>
-              <a:t>359</a:t>
+              <a:t>370</a:t>
             </a:r>
             <a:endParaRPr lang="en-US" sz="3800" dirty="0"/>
           </a:p>
@@ -14672,7 +14672,7 @@
                 <a:ea typeface="Consolas" pitchFamily="34" charset="-122"/>
                 <a:cs typeface="Consolas" pitchFamily="34" charset="-120"/>
               </a:rPr>
-              <a:t>104</a:t>
+              <a:t>106</a:t>
             </a:r>
             <a:endParaRPr lang="en-US" sz="3800" dirty="0"/>
           </a:p>
@@ -15424,7 +15424,7 @@
                 <a:ea typeface="Calibri" pitchFamily="34" charset="-122"/>
                 <a:cs typeface="Calibri" pitchFamily="34" charset="-120"/>
               </a:rPr>
-              <a:t>Re-derive rather than trust: npm test · python -m pytest · ls supabase/migrations/*.sql. 372 JavaScript tests are defined; 359 run without production credentials.</a:t>
+              <a:t>Re-derive rather than trust: npm test · python -m pytest · ls supabase/migrations/*.sql. 382 JavaScript tests are defined; 370 run without production credentials.</a:t>
             </a:r>
             <a:endParaRPr lang="en-US" sz="1050" dirty="0"/>
           </a:p>
@@ -23660,7 +23660,7 @@
                 <a:ea typeface="Calibri" pitchFamily="34" charset="-122"/>
                 <a:cs typeface="Calibri" pitchFamily="34" charset="-120"/>
               </a:rPr>
-              <a:t>372 JavaScript tests and 36 Python tests; 13 of them need production credentials.</a:t>
+              <a:t>382 JavaScript tests and 36 Python tests; 12 of them need production credentials.</a:t>
             </a:r>
             <a:endParaRPr lang="en-US" sz="1100" dirty="0"/>
           </a:p>

</xml_diff>